<commit_message>
Added Ck to open Deck
</commit_message>
<xml_diff>
--- a/schedule/01-welcome-kickoff/01-welcome-kickoff.pptx
+++ b/schedule/01-welcome-kickoff/01-welcome-kickoff.pptx
@@ -5,7 +5,7 @@
     <p:sldMasterId id="2147483648" r:id="rId1"/>
   </p:sldMasterIdLst>
   <p:notesMasterIdLst>
-    <p:notesMasterId r:id="rId14"/>
+    <p:notesMasterId r:id="rId13"/>
   </p:notesMasterIdLst>
   <p:sldIdLst>
     <p:sldId id="267" r:id="rId2"/>
@@ -18,8 +18,7 @@
     <p:sldId id="262" r:id="rId9"/>
     <p:sldId id="268" r:id="rId10"/>
     <p:sldId id="263" r:id="rId11"/>
-    <p:sldId id="264" r:id="rId12"/>
-    <p:sldId id="265" r:id="rId13"/>
+    <p:sldId id="265" r:id="rId12"/>
   </p:sldIdLst>
   <p:sldSz cx="12192000" cy="6858000"/>
   <p:notesSz cx="6858000" cy="12192000"/>
@@ -752,7 +751,7 @@
           <a:p>
             <a:r>
               <a:rPr lang="en-US" dirty="0"/>
-              <a:t>Don't explain it deeply — that's later in the day. Just say the letters out loud once so the room's heard it. By Day 2 it should feel familiar.</a:t>
+              <a:t>Land it, smile, hand off cleanly. Don't oversell the next session — let it speak for itself. Last words: 'Let's build.'</a:t>
             </a:r>
           </a:p>
         </p:txBody>
@@ -775,93 +774,6 @@
             <a:fld id="{F7021451-1387-4CA6-816F-3879F97B5CBC}" type="slidenum">
               <a:rPr lang="en-US"/>
               <a:t>11</a:t>
-            </a:fld>
-            <a:endParaRPr lang="en-US"/>
-          </a:p>
-        </p:txBody>
-      </p:sp>
-    </p:spTree>
-    <p:extLst>
-      <p:ext uri="{BB962C8B-B14F-4D97-AF65-F5344CB8AC3E}">
-        <p14:creationId xmlns:p14="http://schemas.microsoft.com/office/powerpoint/2010/main" val="1024086991"/>
-      </p:ext>
-    </p:extLst>
-  </p:cSld>
-  <p:clrMapOvr>
-    <a:masterClrMapping/>
-  </p:clrMapOvr>
-</p:notes>
-</file>
-
-<file path=ppt/notesSlides/notesSlide12.xml><?xml version="1.0" encoding="utf-8"?>
-<p:notes xmlns:a="http://schemas.openxmlformats.org/drawingml/2006/main" xmlns:r="http://schemas.openxmlformats.org/officeDocument/2006/relationships" xmlns:p="http://schemas.openxmlformats.org/presentationml/2006/main">
-  <p:cSld>
-    <p:spTree>
-      <p:nvGrpSpPr>
-        <p:cNvPr id="1" name=""/>
-        <p:cNvGrpSpPr/>
-        <p:nvPr/>
-      </p:nvGrpSpPr>
-      <p:grpSpPr>
-        <a:xfrm>
-          <a:off x="0" y="0"/>
-          <a:ext cx="0" cy="0"/>
-          <a:chOff x="0" y="0"/>
-          <a:chExt cx="0" cy="0"/>
-        </a:xfrm>
-      </p:grpSpPr>
-      <p:sp>
-        <p:nvSpPr>
-          <p:cNvPr id="2" name="Slide Image Placeholder 1"/>
-          <p:cNvSpPr>
-            <a:spLocks noGrp="1" noRot="1" noChangeAspect="1"/>
-          </p:cNvSpPr>
-          <p:nvPr>
-            <p:ph type="sldImg"/>
-          </p:nvPr>
-        </p:nvSpPr>
-        <p:spPr/>
-      </p:sp>
-      <p:sp>
-        <p:nvSpPr>
-          <p:cNvPr id="3" name="Notes Placeholder 2"/>
-          <p:cNvSpPr>
-            <a:spLocks noGrp="1"/>
-          </p:cNvSpPr>
-          <p:nvPr>
-            <p:ph type="body" idx="1"/>
-          </p:nvPr>
-        </p:nvSpPr>
-        <p:spPr/>
-        <p:txBody>
-          <a:bodyPr/>
-          <a:lstStyle/>
-          <a:p>
-            <a:r>
-              <a:rPr lang="en-US" dirty="0"/>
-              <a:t>Land it, smile, hand off cleanly. Don't oversell the next session — let it speak for itself. Last words: 'Let's build.'</a:t>
-            </a:r>
-          </a:p>
-        </p:txBody>
-      </p:sp>
-      <p:sp>
-        <p:nvSpPr>
-          <p:cNvPr id="4" name="Slide Number Placeholder 3"/>
-          <p:cNvSpPr>
-            <a:spLocks noGrp="1"/>
-          </p:cNvSpPr>
-          <p:nvPr>
-            <p:ph type="sldNum" sz="quarter" idx="10"/>
-          </p:nvPr>
-        </p:nvSpPr>
-        <p:spPr/>
-        <p:txBody>
-          <a:bodyPr/>
-          <a:lstStyle/>
-          <a:p>
-            <a:fld id="{F7021451-1387-4CA6-816F-3879F97B5CBC}" type="slidenum">
-              <a:rPr lang="en-US"/>
-              <a:t>12</a:t>
             </a:fld>
             <a:endParaRPr lang="en-US"/>
           </a:p>
@@ -2508,45 +2420,6 @@
       </p:sp>
       <p:sp>
         <p:nvSpPr>
-          <p:cNvPr id="4" name="Text 2"/>
-          <p:cNvSpPr/>
-          <p:nvPr/>
-        </p:nvSpPr>
-        <p:spPr>
-          <a:xfrm>
-            <a:off x="548640" y="1783080"/>
-            <a:ext cx="10972800" cy="457200"/>
-          </a:xfrm>
-          <a:prstGeom prst="rect">
-            <a:avLst/>
-          </a:prstGeom>
-          <a:noFill/>
-          <a:ln/>
-        </p:spPr>
-        <p:txBody>
-          <a:bodyPr wrap="square" lIns="0" tIns="0" rIns="0" bIns="0" rtlCol="0" anchor="ctr"/>
-          <a:lstStyle/>
-          <a:p>
-            <a:pPr marL="0" indent="0">
-              <a:buNone/>
-            </a:pPr>
-            <a:r>
-              <a:rPr lang="en-US" sz="1400" i="1" dirty="0">
-                <a:solidFill>
-                  <a:srgbClr val="6B7280"/>
-                </a:solidFill>
-                <a:latin typeface="Inter" pitchFamily="34" charset="0"/>
-                <a:ea typeface="Inter" pitchFamily="34" charset="-122"/>
-                <a:cs typeface="Inter" pitchFamily="34" charset="-120"/>
-              </a:rPr>
-              <a:t>Three green checks and you're ready for Day 1. Anything red? Find Tripp or Patrick at the 10:15 break.</a:t>
-            </a:r>
-            <a:endParaRPr lang="en-US" sz="1400" dirty="0"/>
-          </a:p>
-        </p:txBody>
-      </p:sp>
-      <p:sp>
-        <p:nvSpPr>
           <p:cNvPr id="5" name="Shape 3"/>
           <p:cNvSpPr/>
           <p:nvPr/>
@@ -3242,7 +3115,7 @@
                 <a:ea typeface="Inter" pitchFamily="34" charset="-122"/>
                 <a:cs typeface="Inter" pitchFamily="34" charset="-120"/>
               </a:rPr>
-              <a:t>If any of those three are red — find them.</a:t>
+              <a:t>If any of those three are red or missing – turn your name plate vertical.</a:t>
             </a:r>
             <a:endParaRPr lang="en-US" sz="1300" dirty="0"/>
           </a:p>
@@ -3369,1290 +3242,6 @@
 </file>
 
 <file path=ppt/slides/slide11.xml><?xml version="1.0" encoding="utf-8"?>
-<p:sld xmlns:a="http://schemas.openxmlformats.org/drawingml/2006/main" xmlns:r="http://schemas.openxmlformats.org/officeDocument/2006/relationships" xmlns:p="http://schemas.openxmlformats.org/presentationml/2006/main">
-  <p:cSld name="Slide 9">
-    <p:bg>
-      <p:bgPr>
-        <a:solidFill>
-          <a:srgbClr val="0F1620"/>
-        </a:solidFill>
-        <a:effectLst/>
-      </p:bgPr>
-    </p:bg>
-    <p:spTree>
-      <p:nvGrpSpPr>
-        <p:cNvPr id="1" name=""/>
-        <p:cNvGrpSpPr/>
-        <p:nvPr/>
-      </p:nvGrpSpPr>
-      <p:grpSpPr>
-        <a:xfrm>
-          <a:off x="0" y="0"/>
-          <a:ext cx="0" cy="0"/>
-          <a:chOff x="0" y="0"/>
-          <a:chExt cx="0" cy="0"/>
-        </a:xfrm>
-      </p:grpSpPr>
-      <p:sp>
-        <p:nvSpPr>
-          <p:cNvPr id="2" name="Text 0"/>
-          <p:cNvSpPr/>
-          <p:nvPr/>
-        </p:nvSpPr>
-        <p:spPr>
-          <a:xfrm>
-            <a:off x="731520" y="548640"/>
-            <a:ext cx="5486400" cy="274320"/>
-          </a:xfrm>
-          <a:prstGeom prst="rect">
-            <a:avLst/>
-          </a:prstGeom>
-          <a:noFill/>
-          <a:ln/>
-        </p:spPr>
-        <p:txBody>
-          <a:bodyPr wrap="square" lIns="0" tIns="0" rIns="0" bIns="0" rtlCol="0" anchor="ctr"/>
-          <a:lstStyle/>
-          <a:p>
-            <a:pPr marL="0" indent="0">
-              <a:buNone/>
-            </a:pPr>
-            <a:r>
-              <a:rPr lang="en-US" sz="1000" b="1" kern="0" spc="600" dirty="0">
-                <a:solidFill>
-                  <a:srgbClr val="E89B3C"/>
-                </a:solidFill>
-                <a:latin typeface="Inter" pitchFamily="34" charset="0"/>
-                <a:ea typeface="Inter" pitchFamily="34" charset="-122"/>
-                <a:cs typeface="Inter" pitchFamily="34" charset="-120"/>
-              </a:rPr>
-              <a:t>AN ACRONYM TO REMEMBER</a:t>
-            </a:r>
-            <a:endParaRPr lang="en-US" sz="1000" dirty="0"/>
-          </a:p>
-        </p:txBody>
-      </p:sp>
-      <p:sp>
-        <p:nvSpPr>
-          <p:cNvPr id="3" name="Text 1"/>
-          <p:cNvSpPr/>
-          <p:nvPr/>
-        </p:nvSpPr>
-        <p:spPr>
-          <a:xfrm>
-            <a:off x="731520" y="868680"/>
-            <a:ext cx="10058400" cy="914400"/>
-          </a:xfrm>
-          <a:prstGeom prst="rect">
-            <a:avLst/>
-          </a:prstGeom>
-          <a:noFill/>
-          <a:ln/>
-        </p:spPr>
-        <p:txBody>
-          <a:bodyPr wrap="square" lIns="0" tIns="0" rIns="0" bIns="0" rtlCol="0" anchor="ctr"/>
-          <a:lstStyle/>
-          <a:p>
-            <a:pPr marL="0" indent="0">
-              <a:buNone/>
-            </a:pPr>
-            <a:r>
-              <a:rPr lang="en-US" sz="6000" b="1" dirty="0">
-                <a:solidFill>
-                  <a:srgbClr val="FFFFFF"/>
-                </a:solidFill>
-                <a:latin typeface="Montserrat" pitchFamily="34" charset="0"/>
-                <a:ea typeface="Montserrat" pitchFamily="34" charset="-122"/>
-                <a:cs typeface="Montserrat" pitchFamily="34" charset="-120"/>
-              </a:rPr>
-              <a:t>PRTDUD.</a:t>
-            </a:r>
-            <a:endParaRPr lang="en-US" sz="6000" dirty="0"/>
-          </a:p>
-        </p:txBody>
-      </p:sp>
-      <p:sp>
-        <p:nvSpPr>
-          <p:cNvPr id="4" name="Text 2"/>
-          <p:cNvSpPr/>
-          <p:nvPr/>
-        </p:nvSpPr>
-        <p:spPr>
-          <a:xfrm>
-            <a:off x="731520" y="1828800"/>
-            <a:ext cx="10972800" cy="457200"/>
-          </a:xfrm>
-          <a:prstGeom prst="rect">
-            <a:avLst/>
-          </a:prstGeom>
-          <a:noFill/>
-          <a:ln/>
-        </p:spPr>
-        <p:txBody>
-          <a:bodyPr wrap="square" lIns="0" tIns="0" rIns="0" bIns="0" rtlCol="0" anchor="ctr"/>
-          <a:lstStyle/>
-          <a:p>
-            <a:pPr marL="0" indent="0">
-              <a:buNone/>
-            </a:pPr>
-            <a:r>
-              <a:rPr lang="en-US" sz="1800" i="1" dirty="0">
-                <a:solidFill>
-                  <a:srgbClr val="9AA3AF"/>
-                </a:solidFill>
-                <a:latin typeface="Montserrat" pitchFamily="34" charset="0"/>
-                <a:ea typeface="Montserrat" pitchFamily="34" charset="-122"/>
-                <a:cs typeface="Montserrat" pitchFamily="34" charset="-120"/>
-              </a:rPr>
-              <a:t>The loop you'll hear all weekend. Plant it now.</a:t>
-            </a:r>
-            <a:endParaRPr lang="en-US" sz="1800" dirty="0"/>
-          </a:p>
-        </p:txBody>
-      </p:sp>
-      <p:sp>
-        <p:nvSpPr>
-          <p:cNvPr id="5" name="Shape 3"/>
-          <p:cNvSpPr/>
-          <p:nvPr/>
-        </p:nvSpPr>
-        <p:spPr>
-          <a:xfrm>
-            <a:off x="563728" y="2834640"/>
-            <a:ext cx="1653540" cy="3017520"/>
-          </a:xfrm>
-          <a:prstGeom prst="rect">
-            <a:avLst/>
-          </a:prstGeom>
-          <a:solidFill>
-            <a:srgbClr val="1B2533"/>
-          </a:solidFill>
-          <a:ln w="6350">
-            <a:solidFill>
-              <a:srgbClr val="2B3543"/>
-            </a:solidFill>
-            <a:prstDash val="solid"/>
-          </a:ln>
-        </p:spPr>
-        <p:txBody>
-          <a:bodyPr/>
-          <a:lstStyle/>
-          <a:p>
-            <a:endParaRPr lang="en-US"/>
-          </a:p>
-        </p:txBody>
-      </p:sp>
-      <p:sp>
-        <p:nvSpPr>
-          <p:cNvPr id="6" name="Shape 4"/>
-          <p:cNvSpPr/>
-          <p:nvPr/>
-        </p:nvSpPr>
-        <p:spPr>
-          <a:xfrm>
-            <a:off x="563728" y="2834640"/>
-            <a:ext cx="1653540" cy="54864"/>
-          </a:xfrm>
-          <a:prstGeom prst="rect">
-            <a:avLst/>
-          </a:prstGeom>
-          <a:solidFill>
-            <a:srgbClr val="3FB6A8"/>
-          </a:solidFill>
-          <a:ln/>
-        </p:spPr>
-        <p:txBody>
-          <a:bodyPr/>
-          <a:lstStyle/>
-          <a:p>
-            <a:endParaRPr lang="en-US"/>
-          </a:p>
-        </p:txBody>
-      </p:sp>
-      <p:sp>
-        <p:nvSpPr>
-          <p:cNvPr id="7" name="Text 5"/>
-          <p:cNvSpPr/>
-          <p:nvPr/>
-        </p:nvSpPr>
-        <p:spPr>
-          <a:xfrm>
-            <a:off x="563728" y="3200400"/>
-            <a:ext cx="1653540" cy="1280160"/>
-          </a:xfrm>
-          <a:prstGeom prst="rect">
-            <a:avLst/>
-          </a:prstGeom>
-          <a:noFill/>
-          <a:ln/>
-        </p:spPr>
-        <p:txBody>
-          <a:bodyPr wrap="square" lIns="0" tIns="0" rIns="0" bIns="0" rtlCol="0" anchor="ctr"/>
-          <a:lstStyle/>
-          <a:p>
-            <a:pPr marL="0" indent="0" algn="ctr">
-              <a:buNone/>
-            </a:pPr>
-            <a:r>
-              <a:rPr lang="en-US" sz="9000" b="1" dirty="0">
-                <a:solidFill>
-                  <a:srgbClr val="3FB6A8"/>
-                </a:solidFill>
-                <a:latin typeface="Montserrat" pitchFamily="34" charset="0"/>
-                <a:ea typeface="Montserrat" pitchFamily="34" charset="-122"/>
-                <a:cs typeface="Montserrat" pitchFamily="34" charset="-120"/>
-              </a:rPr>
-              <a:t>P</a:t>
-            </a:r>
-            <a:endParaRPr lang="en-US" sz="9000" dirty="0"/>
-          </a:p>
-        </p:txBody>
-      </p:sp>
-      <p:sp>
-        <p:nvSpPr>
-          <p:cNvPr id="8" name="Text 6"/>
-          <p:cNvSpPr/>
-          <p:nvPr/>
-        </p:nvSpPr>
-        <p:spPr>
-          <a:xfrm>
-            <a:off x="563728" y="4526280"/>
-            <a:ext cx="1653540" cy="457200"/>
-          </a:xfrm>
-          <a:prstGeom prst="rect">
-            <a:avLst/>
-          </a:prstGeom>
-          <a:noFill/>
-          <a:ln/>
-        </p:spPr>
-        <p:txBody>
-          <a:bodyPr wrap="square" lIns="0" tIns="0" rIns="0" bIns="0" rtlCol="0" anchor="ctr"/>
-          <a:lstStyle/>
-          <a:p>
-            <a:pPr marL="0" indent="0" algn="ctr">
-              <a:buNone/>
-            </a:pPr>
-            <a:r>
-              <a:rPr lang="en-US" sz="1800" b="1" dirty="0">
-                <a:solidFill>
-                  <a:srgbClr val="FFFFFF"/>
-                </a:solidFill>
-                <a:latin typeface="Montserrat" pitchFamily="34" charset="0"/>
-                <a:ea typeface="Montserrat" pitchFamily="34" charset="-122"/>
-                <a:cs typeface="Montserrat" pitchFamily="34" charset="-120"/>
-              </a:rPr>
-              <a:t>Plan</a:t>
-            </a:r>
-            <a:endParaRPr lang="en-US" sz="1800" dirty="0"/>
-          </a:p>
-        </p:txBody>
-      </p:sp>
-      <p:sp>
-        <p:nvSpPr>
-          <p:cNvPr id="9" name="Text 7"/>
-          <p:cNvSpPr/>
-          <p:nvPr/>
-        </p:nvSpPr>
-        <p:spPr>
-          <a:xfrm>
-            <a:off x="700888" y="5074920"/>
-            <a:ext cx="1379220" cy="640080"/>
-          </a:xfrm>
-          <a:prstGeom prst="rect">
-            <a:avLst/>
-          </a:prstGeom>
-          <a:noFill/>
-          <a:ln/>
-        </p:spPr>
-        <p:txBody>
-          <a:bodyPr wrap="square" lIns="0" tIns="0" rIns="0" bIns="0" rtlCol="0" anchor="ctr"/>
-          <a:lstStyle/>
-          <a:p>
-            <a:pPr marL="0" indent="0" algn="ctr">
-              <a:buNone/>
-            </a:pPr>
-            <a:r>
-              <a:rPr lang="en-US" sz="1100" dirty="0">
-                <a:solidFill>
-                  <a:srgbClr val="9AA3AF"/>
-                </a:solidFill>
-                <a:latin typeface="Inter" pitchFamily="34" charset="0"/>
-                <a:ea typeface="Inter" pitchFamily="34" charset="-122"/>
-                <a:cs typeface="Inter" pitchFamily="34" charset="-120"/>
-              </a:rPr>
-              <a:t>Spec it in writing.</a:t>
-            </a:r>
-            <a:endParaRPr lang="en-US" sz="1100" dirty="0"/>
-          </a:p>
-        </p:txBody>
-      </p:sp>
-      <p:sp>
-        <p:nvSpPr>
-          <p:cNvPr id="10" name="Shape 8"/>
-          <p:cNvSpPr/>
-          <p:nvPr/>
-        </p:nvSpPr>
-        <p:spPr>
-          <a:xfrm>
-            <a:off x="2445868" y="2834640"/>
-            <a:ext cx="1653540" cy="3017520"/>
-          </a:xfrm>
-          <a:prstGeom prst="rect">
-            <a:avLst/>
-          </a:prstGeom>
-          <a:solidFill>
-            <a:srgbClr val="1B2533"/>
-          </a:solidFill>
-          <a:ln w="6350">
-            <a:solidFill>
-              <a:srgbClr val="2B3543"/>
-            </a:solidFill>
-            <a:prstDash val="solid"/>
-          </a:ln>
-        </p:spPr>
-        <p:txBody>
-          <a:bodyPr/>
-          <a:lstStyle/>
-          <a:p>
-            <a:endParaRPr lang="en-US"/>
-          </a:p>
-        </p:txBody>
-      </p:sp>
-      <p:sp>
-        <p:nvSpPr>
-          <p:cNvPr id="11" name="Shape 9"/>
-          <p:cNvSpPr/>
-          <p:nvPr/>
-        </p:nvSpPr>
-        <p:spPr>
-          <a:xfrm>
-            <a:off x="2445868" y="2834640"/>
-            <a:ext cx="1653540" cy="54864"/>
-          </a:xfrm>
-          <a:prstGeom prst="rect">
-            <a:avLst/>
-          </a:prstGeom>
-          <a:solidFill>
-            <a:srgbClr val="E89B3C"/>
-          </a:solidFill>
-          <a:ln/>
-        </p:spPr>
-        <p:txBody>
-          <a:bodyPr/>
-          <a:lstStyle/>
-          <a:p>
-            <a:endParaRPr lang="en-US"/>
-          </a:p>
-        </p:txBody>
-      </p:sp>
-      <p:sp>
-        <p:nvSpPr>
-          <p:cNvPr id="12" name="Text 10"/>
-          <p:cNvSpPr/>
-          <p:nvPr/>
-        </p:nvSpPr>
-        <p:spPr>
-          <a:xfrm>
-            <a:off x="2445868" y="3200400"/>
-            <a:ext cx="1653540" cy="1280160"/>
-          </a:xfrm>
-          <a:prstGeom prst="rect">
-            <a:avLst/>
-          </a:prstGeom>
-          <a:noFill/>
-          <a:ln/>
-        </p:spPr>
-        <p:txBody>
-          <a:bodyPr wrap="square" lIns="0" tIns="0" rIns="0" bIns="0" rtlCol="0" anchor="ctr"/>
-          <a:lstStyle/>
-          <a:p>
-            <a:pPr marL="0" indent="0" algn="ctr">
-              <a:buNone/>
-            </a:pPr>
-            <a:r>
-              <a:rPr lang="en-US" sz="9000" b="1" dirty="0">
-                <a:solidFill>
-                  <a:srgbClr val="E89B3C"/>
-                </a:solidFill>
-                <a:latin typeface="Montserrat" pitchFamily="34" charset="0"/>
-                <a:ea typeface="Montserrat" pitchFamily="34" charset="-122"/>
-                <a:cs typeface="Montserrat" pitchFamily="34" charset="-120"/>
-              </a:rPr>
-              <a:t>R</a:t>
-            </a:r>
-            <a:endParaRPr lang="en-US" sz="9000" dirty="0"/>
-          </a:p>
-        </p:txBody>
-      </p:sp>
-      <p:sp>
-        <p:nvSpPr>
-          <p:cNvPr id="13" name="Text 11"/>
-          <p:cNvSpPr/>
-          <p:nvPr/>
-        </p:nvSpPr>
-        <p:spPr>
-          <a:xfrm>
-            <a:off x="2445868" y="4526280"/>
-            <a:ext cx="1653540" cy="457200"/>
-          </a:xfrm>
-          <a:prstGeom prst="rect">
-            <a:avLst/>
-          </a:prstGeom>
-          <a:noFill/>
-          <a:ln/>
-        </p:spPr>
-        <p:txBody>
-          <a:bodyPr wrap="square" lIns="0" tIns="0" rIns="0" bIns="0" rtlCol="0" anchor="ctr"/>
-          <a:lstStyle/>
-          <a:p>
-            <a:pPr marL="0" indent="0" algn="ctr">
-              <a:buNone/>
-            </a:pPr>
-            <a:r>
-              <a:rPr lang="en-US" sz="1800" b="1" dirty="0">
-                <a:solidFill>
-                  <a:srgbClr val="FFFFFF"/>
-                </a:solidFill>
-                <a:latin typeface="Montserrat" pitchFamily="34" charset="0"/>
-                <a:ea typeface="Montserrat" pitchFamily="34" charset="-122"/>
-                <a:cs typeface="Montserrat" pitchFamily="34" charset="-120"/>
-              </a:rPr>
-              <a:t>Review</a:t>
-            </a:r>
-            <a:endParaRPr lang="en-US" sz="1800" dirty="0"/>
-          </a:p>
-        </p:txBody>
-      </p:sp>
-      <p:sp>
-        <p:nvSpPr>
-          <p:cNvPr id="14" name="Text 12"/>
-          <p:cNvSpPr/>
-          <p:nvPr/>
-        </p:nvSpPr>
-        <p:spPr>
-          <a:xfrm>
-            <a:off x="2583028" y="5074920"/>
-            <a:ext cx="1379220" cy="640080"/>
-          </a:xfrm>
-          <a:prstGeom prst="rect">
-            <a:avLst/>
-          </a:prstGeom>
-          <a:noFill/>
-          <a:ln/>
-        </p:spPr>
-        <p:txBody>
-          <a:bodyPr wrap="square" lIns="0" tIns="0" rIns="0" bIns="0" rtlCol="0" anchor="ctr"/>
-          <a:lstStyle/>
-          <a:p>
-            <a:pPr marL="0" indent="0" algn="ctr">
-              <a:buNone/>
-            </a:pPr>
-            <a:r>
-              <a:rPr lang="en-US" sz="1100" dirty="0">
-                <a:solidFill>
-                  <a:srgbClr val="9AA3AF"/>
-                </a:solidFill>
-                <a:latin typeface="Inter" pitchFamily="34" charset="0"/>
-                <a:ea typeface="Inter" pitchFamily="34" charset="-122"/>
-                <a:cs typeface="Inter" pitchFamily="34" charset="-120"/>
-              </a:rPr>
-              <a:t>Read before you run.</a:t>
-            </a:r>
-            <a:endParaRPr lang="en-US" sz="1100" dirty="0"/>
-          </a:p>
-        </p:txBody>
-      </p:sp>
-      <p:sp>
-        <p:nvSpPr>
-          <p:cNvPr id="15" name="Shape 13"/>
-          <p:cNvSpPr/>
-          <p:nvPr/>
-        </p:nvSpPr>
-        <p:spPr>
-          <a:xfrm>
-            <a:off x="4328008" y="2834640"/>
-            <a:ext cx="1653540" cy="3017520"/>
-          </a:xfrm>
-          <a:prstGeom prst="rect">
-            <a:avLst/>
-          </a:prstGeom>
-          <a:solidFill>
-            <a:srgbClr val="1B2533"/>
-          </a:solidFill>
-          <a:ln w="6350">
-            <a:solidFill>
-              <a:srgbClr val="2B3543"/>
-            </a:solidFill>
-            <a:prstDash val="solid"/>
-          </a:ln>
-        </p:spPr>
-        <p:txBody>
-          <a:bodyPr/>
-          <a:lstStyle/>
-          <a:p>
-            <a:endParaRPr lang="en-US"/>
-          </a:p>
-        </p:txBody>
-      </p:sp>
-      <p:sp>
-        <p:nvSpPr>
-          <p:cNvPr id="16" name="Shape 14"/>
-          <p:cNvSpPr/>
-          <p:nvPr/>
-        </p:nvSpPr>
-        <p:spPr>
-          <a:xfrm>
-            <a:off x="4328008" y="2834640"/>
-            <a:ext cx="1653540" cy="54864"/>
-          </a:xfrm>
-          <a:prstGeom prst="rect">
-            <a:avLst/>
-          </a:prstGeom>
-          <a:solidFill>
-            <a:srgbClr val="3FB6A8"/>
-          </a:solidFill>
-          <a:ln/>
-        </p:spPr>
-        <p:txBody>
-          <a:bodyPr/>
-          <a:lstStyle/>
-          <a:p>
-            <a:endParaRPr lang="en-US"/>
-          </a:p>
-        </p:txBody>
-      </p:sp>
-      <p:sp>
-        <p:nvSpPr>
-          <p:cNvPr id="17" name="Text 15"/>
-          <p:cNvSpPr/>
-          <p:nvPr/>
-        </p:nvSpPr>
-        <p:spPr>
-          <a:xfrm>
-            <a:off x="4328008" y="3200400"/>
-            <a:ext cx="1653540" cy="1280160"/>
-          </a:xfrm>
-          <a:prstGeom prst="rect">
-            <a:avLst/>
-          </a:prstGeom>
-          <a:noFill/>
-          <a:ln/>
-        </p:spPr>
-        <p:txBody>
-          <a:bodyPr wrap="square" lIns="0" tIns="0" rIns="0" bIns="0" rtlCol="0" anchor="ctr"/>
-          <a:lstStyle/>
-          <a:p>
-            <a:pPr marL="0" indent="0" algn="ctr">
-              <a:buNone/>
-            </a:pPr>
-            <a:r>
-              <a:rPr lang="en-US" sz="9000" b="1" dirty="0">
-                <a:solidFill>
-                  <a:srgbClr val="3FB6A8"/>
-                </a:solidFill>
-                <a:latin typeface="Montserrat" pitchFamily="34" charset="0"/>
-                <a:ea typeface="Montserrat" pitchFamily="34" charset="-122"/>
-                <a:cs typeface="Montserrat" pitchFamily="34" charset="-120"/>
-              </a:rPr>
-              <a:t>T</a:t>
-            </a:r>
-            <a:endParaRPr lang="en-US" sz="9000" dirty="0"/>
-          </a:p>
-        </p:txBody>
-      </p:sp>
-      <p:sp>
-        <p:nvSpPr>
-          <p:cNvPr id="18" name="Text 16"/>
-          <p:cNvSpPr/>
-          <p:nvPr/>
-        </p:nvSpPr>
-        <p:spPr>
-          <a:xfrm>
-            <a:off x="4328008" y="4526280"/>
-            <a:ext cx="1653540" cy="457200"/>
-          </a:xfrm>
-          <a:prstGeom prst="rect">
-            <a:avLst/>
-          </a:prstGeom>
-          <a:noFill/>
-          <a:ln/>
-        </p:spPr>
-        <p:txBody>
-          <a:bodyPr wrap="square" lIns="0" tIns="0" rIns="0" bIns="0" rtlCol="0" anchor="ctr"/>
-          <a:lstStyle/>
-          <a:p>
-            <a:pPr marL="0" indent="0" algn="ctr">
-              <a:buNone/>
-            </a:pPr>
-            <a:r>
-              <a:rPr lang="en-US" sz="1800" b="1" dirty="0">
-                <a:solidFill>
-                  <a:srgbClr val="FFFFFF"/>
-                </a:solidFill>
-                <a:latin typeface="Montserrat" pitchFamily="34" charset="0"/>
-                <a:ea typeface="Montserrat" pitchFamily="34" charset="-122"/>
-                <a:cs typeface="Montserrat" pitchFamily="34" charset="-120"/>
-              </a:rPr>
-              <a:t>Test</a:t>
-            </a:r>
-            <a:endParaRPr lang="en-US" sz="1800" dirty="0"/>
-          </a:p>
-        </p:txBody>
-      </p:sp>
-      <p:sp>
-        <p:nvSpPr>
-          <p:cNvPr id="19" name="Text 17"/>
-          <p:cNvSpPr/>
-          <p:nvPr/>
-        </p:nvSpPr>
-        <p:spPr>
-          <a:xfrm>
-            <a:off x="4465168" y="5074920"/>
-            <a:ext cx="1379220" cy="640080"/>
-          </a:xfrm>
-          <a:prstGeom prst="rect">
-            <a:avLst/>
-          </a:prstGeom>
-          <a:noFill/>
-          <a:ln/>
-        </p:spPr>
-        <p:txBody>
-          <a:bodyPr wrap="square" lIns="0" tIns="0" rIns="0" bIns="0" rtlCol="0" anchor="ctr"/>
-          <a:lstStyle/>
-          <a:p>
-            <a:pPr marL="0" indent="0" algn="ctr">
-              <a:buNone/>
-            </a:pPr>
-            <a:r>
-              <a:rPr lang="en-US" sz="1100" dirty="0">
-                <a:solidFill>
-                  <a:srgbClr val="9AA3AF"/>
-                </a:solidFill>
-                <a:latin typeface="Inter" pitchFamily="34" charset="0"/>
-                <a:ea typeface="Inter" pitchFamily="34" charset="-122"/>
-                <a:cs typeface="Inter" pitchFamily="34" charset="-120"/>
-              </a:rPr>
-              <a:t>Prove it works.</a:t>
-            </a:r>
-            <a:endParaRPr lang="en-US" sz="1100" dirty="0"/>
-          </a:p>
-        </p:txBody>
-      </p:sp>
-      <p:sp>
-        <p:nvSpPr>
-          <p:cNvPr id="20" name="Shape 18"/>
-          <p:cNvSpPr/>
-          <p:nvPr/>
-        </p:nvSpPr>
-        <p:spPr>
-          <a:xfrm>
-            <a:off x="6210148" y="2834640"/>
-            <a:ext cx="1653540" cy="3017520"/>
-          </a:xfrm>
-          <a:prstGeom prst="rect">
-            <a:avLst/>
-          </a:prstGeom>
-          <a:solidFill>
-            <a:srgbClr val="1B2533"/>
-          </a:solidFill>
-          <a:ln w="6350">
-            <a:solidFill>
-              <a:srgbClr val="2B3543"/>
-            </a:solidFill>
-            <a:prstDash val="solid"/>
-          </a:ln>
-        </p:spPr>
-        <p:txBody>
-          <a:bodyPr/>
-          <a:lstStyle/>
-          <a:p>
-            <a:endParaRPr lang="en-US"/>
-          </a:p>
-        </p:txBody>
-      </p:sp>
-      <p:sp>
-        <p:nvSpPr>
-          <p:cNvPr id="21" name="Shape 19"/>
-          <p:cNvSpPr/>
-          <p:nvPr/>
-        </p:nvSpPr>
-        <p:spPr>
-          <a:xfrm>
-            <a:off x="6210148" y="2834640"/>
-            <a:ext cx="1653540" cy="54864"/>
-          </a:xfrm>
-          <a:prstGeom prst="rect">
-            <a:avLst/>
-          </a:prstGeom>
-          <a:solidFill>
-            <a:srgbClr val="E89B3C"/>
-          </a:solidFill>
-          <a:ln/>
-        </p:spPr>
-        <p:txBody>
-          <a:bodyPr/>
-          <a:lstStyle/>
-          <a:p>
-            <a:endParaRPr lang="en-US"/>
-          </a:p>
-        </p:txBody>
-      </p:sp>
-      <p:sp>
-        <p:nvSpPr>
-          <p:cNvPr id="22" name="Text 20"/>
-          <p:cNvSpPr/>
-          <p:nvPr/>
-        </p:nvSpPr>
-        <p:spPr>
-          <a:xfrm>
-            <a:off x="6210148" y="3200400"/>
-            <a:ext cx="1653540" cy="1280160"/>
-          </a:xfrm>
-          <a:prstGeom prst="rect">
-            <a:avLst/>
-          </a:prstGeom>
-          <a:noFill/>
-          <a:ln/>
-        </p:spPr>
-        <p:txBody>
-          <a:bodyPr wrap="square" lIns="0" tIns="0" rIns="0" bIns="0" rtlCol="0" anchor="ctr"/>
-          <a:lstStyle/>
-          <a:p>
-            <a:pPr marL="0" indent="0" algn="ctr">
-              <a:buNone/>
-            </a:pPr>
-            <a:r>
-              <a:rPr lang="en-US" sz="9000" b="1" dirty="0">
-                <a:solidFill>
-                  <a:srgbClr val="E89B3C"/>
-                </a:solidFill>
-                <a:latin typeface="Montserrat" pitchFamily="34" charset="0"/>
-                <a:ea typeface="Montserrat" pitchFamily="34" charset="-122"/>
-                <a:cs typeface="Montserrat" pitchFamily="34" charset="-120"/>
-              </a:rPr>
-              <a:t>D</a:t>
-            </a:r>
-            <a:endParaRPr lang="en-US" sz="9000" dirty="0"/>
-          </a:p>
-        </p:txBody>
-      </p:sp>
-      <p:sp>
-        <p:nvSpPr>
-          <p:cNvPr id="23" name="Text 21"/>
-          <p:cNvSpPr/>
-          <p:nvPr/>
-        </p:nvSpPr>
-        <p:spPr>
-          <a:xfrm>
-            <a:off x="6210148" y="4526280"/>
-            <a:ext cx="1653540" cy="457200"/>
-          </a:xfrm>
-          <a:prstGeom prst="rect">
-            <a:avLst/>
-          </a:prstGeom>
-          <a:noFill/>
-          <a:ln/>
-        </p:spPr>
-        <p:txBody>
-          <a:bodyPr wrap="square" lIns="0" tIns="0" rIns="0" bIns="0" rtlCol="0" anchor="ctr"/>
-          <a:lstStyle/>
-          <a:p>
-            <a:pPr marL="0" indent="0" algn="ctr">
-              <a:buNone/>
-            </a:pPr>
-            <a:r>
-              <a:rPr lang="en-US" sz="1800" b="1" dirty="0">
-                <a:solidFill>
-                  <a:srgbClr val="FFFFFF"/>
-                </a:solidFill>
-                <a:latin typeface="Montserrat" pitchFamily="34" charset="0"/>
-                <a:ea typeface="Montserrat" pitchFamily="34" charset="-122"/>
-                <a:cs typeface="Montserrat" pitchFamily="34" charset="-120"/>
-              </a:rPr>
-              <a:t>Debug</a:t>
-            </a:r>
-            <a:endParaRPr lang="en-US" sz="1800" dirty="0"/>
-          </a:p>
-        </p:txBody>
-      </p:sp>
-      <p:sp>
-        <p:nvSpPr>
-          <p:cNvPr id="24" name="Text 22"/>
-          <p:cNvSpPr/>
-          <p:nvPr/>
-        </p:nvSpPr>
-        <p:spPr>
-          <a:xfrm>
-            <a:off x="6347308" y="5074920"/>
-            <a:ext cx="1379220" cy="640080"/>
-          </a:xfrm>
-          <a:prstGeom prst="rect">
-            <a:avLst/>
-          </a:prstGeom>
-          <a:noFill/>
-          <a:ln/>
-        </p:spPr>
-        <p:txBody>
-          <a:bodyPr wrap="square" lIns="0" tIns="0" rIns="0" bIns="0" rtlCol="0" anchor="ctr"/>
-          <a:lstStyle/>
-          <a:p>
-            <a:pPr marL="0" indent="0" algn="ctr">
-              <a:buNone/>
-            </a:pPr>
-            <a:r>
-              <a:rPr lang="en-US" sz="1100" dirty="0">
-                <a:solidFill>
-                  <a:srgbClr val="9AA3AF"/>
-                </a:solidFill>
-                <a:latin typeface="Inter" pitchFamily="34" charset="0"/>
-                <a:ea typeface="Inter" pitchFamily="34" charset="-122"/>
-                <a:cs typeface="Inter" pitchFamily="34" charset="-120"/>
-              </a:rPr>
-              <a:t>Hunt the why.</a:t>
-            </a:r>
-            <a:endParaRPr lang="en-US" sz="1100" dirty="0"/>
-          </a:p>
-        </p:txBody>
-      </p:sp>
-      <p:sp>
-        <p:nvSpPr>
-          <p:cNvPr id="25" name="Shape 23"/>
-          <p:cNvSpPr/>
-          <p:nvPr/>
-        </p:nvSpPr>
-        <p:spPr>
-          <a:xfrm>
-            <a:off x="8092288" y="2834640"/>
-            <a:ext cx="1653540" cy="3017520"/>
-          </a:xfrm>
-          <a:prstGeom prst="rect">
-            <a:avLst/>
-          </a:prstGeom>
-          <a:solidFill>
-            <a:srgbClr val="1B2533"/>
-          </a:solidFill>
-          <a:ln w="6350">
-            <a:solidFill>
-              <a:srgbClr val="2B3543"/>
-            </a:solidFill>
-            <a:prstDash val="solid"/>
-          </a:ln>
-        </p:spPr>
-        <p:txBody>
-          <a:bodyPr/>
-          <a:lstStyle/>
-          <a:p>
-            <a:endParaRPr lang="en-US"/>
-          </a:p>
-        </p:txBody>
-      </p:sp>
-      <p:sp>
-        <p:nvSpPr>
-          <p:cNvPr id="26" name="Shape 24"/>
-          <p:cNvSpPr/>
-          <p:nvPr/>
-        </p:nvSpPr>
-        <p:spPr>
-          <a:xfrm>
-            <a:off x="8092288" y="2834640"/>
-            <a:ext cx="1653540" cy="54864"/>
-          </a:xfrm>
-          <a:prstGeom prst="rect">
-            <a:avLst/>
-          </a:prstGeom>
-          <a:solidFill>
-            <a:srgbClr val="3FB6A8"/>
-          </a:solidFill>
-          <a:ln/>
-        </p:spPr>
-        <p:txBody>
-          <a:bodyPr/>
-          <a:lstStyle/>
-          <a:p>
-            <a:endParaRPr lang="en-US"/>
-          </a:p>
-        </p:txBody>
-      </p:sp>
-      <p:sp>
-        <p:nvSpPr>
-          <p:cNvPr id="27" name="Text 25"/>
-          <p:cNvSpPr/>
-          <p:nvPr/>
-        </p:nvSpPr>
-        <p:spPr>
-          <a:xfrm>
-            <a:off x="8092288" y="3200400"/>
-            <a:ext cx="1653540" cy="1280160"/>
-          </a:xfrm>
-          <a:prstGeom prst="rect">
-            <a:avLst/>
-          </a:prstGeom>
-          <a:noFill/>
-          <a:ln/>
-        </p:spPr>
-        <p:txBody>
-          <a:bodyPr wrap="square" lIns="0" tIns="0" rIns="0" bIns="0" rtlCol="0" anchor="ctr"/>
-          <a:lstStyle/>
-          <a:p>
-            <a:pPr marL="0" indent="0" algn="ctr">
-              <a:buNone/>
-            </a:pPr>
-            <a:r>
-              <a:rPr lang="en-US" sz="9000" b="1" dirty="0">
-                <a:solidFill>
-                  <a:srgbClr val="3FB6A8"/>
-                </a:solidFill>
-                <a:latin typeface="Montserrat" pitchFamily="34" charset="0"/>
-                <a:ea typeface="Montserrat" pitchFamily="34" charset="-122"/>
-                <a:cs typeface="Montserrat" pitchFamily="34" charset="-120"/>
-              </a:rPr>
-              <a:t>U</a:t>
-            </a:r>
-            <a:endParaRPr lang="en-US" sz="9000" dirty="0"/>
-          </a:p>
-        </p:txBody>
-      </p:sp>
-      <p:sp>
-        <p:nvSpPr>
-          <p:cNvPr id="28" name="Text 26"/>
-          <p:cNvSpPr/>
-          <p:nvPr/>
-        </p:nvSpPr>
-        <p:spPr>
-          <a:xfrm>
-            <a:off x="8092288" y="4526280"/>
-            <a:ext cx="1653540" cy="457200"/>
-          </a:xfrm>
-          <a:prstGeom prst="rect">
-            <a:avLst/>
-          </a:prstGeom>
-          <a:noFill/>
-          <a:ln/>
-        </p:spPr>
-        <p:txBody>
-          <a:bodyPr wrap="square" lIns="0" tIns="0" rIns="0" bIns="0" rtlCol="0" anchor="ctr"/>
-          <a:lstStyle/>
-          <a:p>
-            <a:pPr marL="0" indent="0" algn="ctr">
-              <a:buNone/>
-            </a:pPr>
-            <a:r>
-              <a:rPr lang="en-US" sz="1800" b="1" dirty="0">
-                <a:solidFill>
-                  <a:srgbClr val="FFFFFF"/>
-                </a:solidFill>
-                <a:latin typeface="Montserrat" pitchFamily="34" charset="0"/>
-                <a:ea typeface="Montserrat" pitchFamily="34" charset="-122"/>
-                <a:cs typeface="Montserrat" pitchFamily="34" charset="-120"/>
-              </a:rPr>
-              <a:t>Update</a:t>
-            </a:r>
-            <a:endParaRPr lang="en-US" sz="1800" dirty="0"/>
-          </a:p>
-        </p:txBody>
-      </p:sp>
-      <p:sp>
-        <p:nvSpPr>
-          <p:cNvPr id="29" name="Text 27"/>
-          <p:cNvSpPr/>
-          <p:nvPr/>
-        </p:nvSpPr>
-        <p:spPr>
-          <a:xfrm>
-            <a:off x="8229448" y="5074920"/>
-            <a:ext cx="1379220" cy="640080"/>
-          </a:xfrm>
-          <a:prstGeom prst="rect">
-            <a:avLst/>
-          </a:prstGeom>
-          <a:noFill/>
-          <a:ln/>
-        </p:spPr>
-        <p:txBody>
-          <a:bodyPr wrap="square" lIns="0" tIns="0" rIns="0" bIns="0" rtlCol="0" anchor="ctr"/>
-          <a:lstStyle/>
-          <a:p>
-            <a:pPr marL="0" indent="0" algn="ctr">
-              <a:buNone/>
-            </a:pPr>
-            <a:r>
-              <a:rPr lang="en-US" sz="1100" dirty="0">
-                <a:solidFill>
-                  <a:srgbClr val="9AA3AF"/>
-                </a:solidFill>
-                <a:latin typeface="Inter" pitchFamily="34" charset="0"/>
-                <a:ea typeface="Inter" pitchFamily="34" charset="-122"/>
-                <a:cs typeface="Inter" pitchFamily="34" charset="-120"/>
-              </a:rPr>
-              <a:t>Edit the context.</a:t>
-            </a:r>
-            <a:endParaRPr lang="en-US" sz="1100" dirty="0"/>
-          </a:p>
-        </p:txBody>
-      </p:sp>
-      <p:sp>
-        <p:nvSpPr>
-          <p:cNvPr id="30" name="Shape 28"/>
-          <p:cNvSpPr/>
-          <p:nvPr/>
-        </p:nvSpPr>
-        <p:spPr>
-          <a:xfrm>
-            <a:off x="9974428" y="2834640"/>
-            <a:ext cx="1653540" cy="3017520"/>
-          </a:xfrm>
-          <a:prstGeom prst="rect">
-            <a:avLst/>
-          </a:prstGeom>
-          <a:solidFill>
-            <a:srgbClr val="1B2533"/>
-          </a:solidFill>
-          <a:ln w="6350">
-            <a:solidFill>
-              <a:srgbClr val="2B3543"/>
-            </a:solidFill>
-            <a:prstDash val="solid"/>
-          </a:ln>
-        </p:spPr>
-        <p:txBody>
-          <a:bodyPr/>
-          <a:lstStyle/>
-          <a:p>
-            <a:endParaRPr lang="en-US"/>
-          </a:p>
-        </p:txBody>
-      </p:sp>
-      <p:sp>
-        <p:nvSpPr>
-          <p:cNvPr id="31" name="Shape 29"/>
-          <p:cNvSpPr/>
-          <p:nvPr/>
-        </p:nvSpPr>
-        <p:spPr>
-          <a:xfrm>
-            <a:off x="9974428" y="2834640"/>
-            <a:ext cx="1653540" cy="54864"/>
-          </a:xfrm>
-          <a:prstGeom prst="rect">
-            <a:avLst/>
-          </a:prstGeom>
-          <a:solidFill>
-            <a:srgbClr val="E89B3C"/>
-          </a:solidFill>
-          <a:ln/>
-        </p:spPr>
-        <p:txBody>
-          <a:bodyPr/>
-          <a:lstStyle/>
-          <a:p>
-            <a:endParaRPr lang="en-US"/>
-          </a:p>
-        </p:txBody>
-      </p:sp>
-      <p:sp>
-        <p:nvSpPr>
-          <p:cNvPr id="32" name="Text 30"/>
-          <p:cNvSpPr/>
-          <p:nvPr/>
-        </p:nvSpPr>
-        <p:spPr>
-          <a:xfrm>
-            <a:off x="9974428" y="3200400"/>
-            <a:ext cx="1653540" cy="1280160"/>
-          </a:xfrm>
-          <a:prstGeom prst="rect">
-            <a:avLst/>
-          </a:prstGeom>
-          <a:noFill/>
-          <a:ln/>
-        </p:spPr>
-        <p:txBody>
-          <a:bodyPr wrap="square" lIns="0" tIns="0" rIns="0" bIns="0" rtlCol="0" anchor="ctr"/>
-          <a:lstStyle/>
-          <a:p>
-            <a:pPr marL="0" indent="0" algn="ctr">
-              <a:buNone/>
-            </a:pPr>
-            <a:r>
-              <a:rPr lang="en-US" sz="9000" b="1" dirty="0">
-                <a:solidFill>
-                  <a:srgbClr val="E89B3C"/>
-                </a:solidFill>
-                <a:latin typeface="Montserrat" pitchFamily="34" charset="0"/>
-                <a:ea typeface="Montserrat" pitchFamily="34" charset="-122"/>
-                <a:cs typeface="Montserrat" pitchFamily="34" charset="-120"/>
-              </a:rPr>
-              <a:t>D</a:t>
-            </a:r>
-            <a:endParaRPr lang="en-US" sz="9000" dirty="0"/>
-          </a:p>
-        </p:txBody>
-      </p:sp>
-      <p:sp>
-        <p:nvSpPr>
-          <p:cNvPr id="33" name="Text 31"/>
-          <p:cNvSpPr/>
-          <p:nvPr/>
-        </p:nvSpPr>
-        <p:spPr>
-          <a:xfrm>
-            <a:off x="9974428" y="4526280"/>
-            <a:ext cx="1653540" cy="457200"/>
-          </a:xfrm>
-          <a:prstGeom prst="rect">
-            <a:avLst/>
-          </a:prstGeom>
-          <a:noFill/>
-          <a:ln/>
-        </p:spPr>
-        <p:txBody>
-          <a:bodyPr wrap="square" lIns="0" tIns="0" rIns="0" bIns="0" rtlCol="0" anchor="ctr"/>
-          <a:lstStyle/>
-          <a:p>
-            <a:pPr marL="0" indent="0" algn="ctr">
-              <a:buNone/>
-            </a:pPr>
-            <a:r>
-              <a:rPr lang="en-US" sz="1800" b="1" dirty="0">
-                <a:solidFill>
-                  <a:srgbClr val="FFFFFF"/>
-                </a:solidFill>
-                <a:latin typeface="Montserrat" pitchFamily="34" charset="0"/>
-                <a:ea typeface="Montserrat" pitchFamily="34" charset="-122"/>
-                <a:cs typeface="Montserrat" pitchFamily="34" charset="-120"/>
-              </a:rPr>
-              <a:t>Deploy</a:t>
-            </a:r>
-            <a:endParaRPr lang="en-US" sz="1800" dirty="0"/>
-          </a:p>
-        </p:txBody>
-      </p:sp>
-      <p:sp>
-        <p:nvSpPr>
-          <p:cNvPr id="34" name="Text 32"/>
-          <p:cNvSpPr/>
-          <p:nvPr/>
-        </p:nvSpPr>
-        <p:spPr>
-          <a:xfrm>
-            <a:off x="10111588" y="5074920"/>
-            <a:ext cx="1379220" cy="640080"/>
-          </a:xfrm>
-          <a:prstGeom prst="rect">
-            <a:avLst/>
-          </a:prstGeom>
-          <a:noFill/>
-          <a:ln/>
-        </p:spPr>
-        <p:txBody>
-          <a:bodyPr wrap="square" lIns="0" tIns="0" rIns="0" bIns="0" rtlCol="0" anchor="ctr"/>
-          <a:lstStyle/>
-          <a:p>
-            <a:pPr marL="0" indent="0" algn="ctr">
-              <a:buNone/>
-            </a:pPr>
-            <a:r>
-              <a:rPr lang="en-US" sz="1100" dirty="0">
-                <a:solidFill>
-                  <a:srgbClr val="9AA3AF"/>
-                </a:solidFill>
-                <a:latin typeface="Inter" pitchFamily="34" charset="0"/>
-                <a:ea typeface="Inter" pitchFamily="34" charset="-122"/>
-                <a:cs typeface="Inter" pitchFamily="34" charset="-120"/>
-              </a:rPr>
-              <a:t>Ship it live.</a:t>
-            </a:r>
-            <a:endParaRPr lang="en-US" sz="1100" dirty="0"/>
-          </a:p>
-        </p:txBody>
-      </p:sp>
-      <p:sp>
-        <p:nvSpPr>
-          <p:cNvPr id="35" name="Text 33"/>
-          <p:cNvSpPr/>
-          <p:nvPr/>
-        </p:nvSpPr>
-        <p:spPr>
-          <a:xfrm>
-            <a:off x="457200" y="6446520"/>
-            <a:ext cx="7315200" cy="274320"/>
-          </a:xfrm>
-          <a:prstGeom prst="rect">
-            <a:avLst/>
-          </a:prstGeom>
-          <a:noFill/>
-          <a:ln/>
-        </p:spPr>
-        <p:txBody>
-          <a:bodyPr wrap="square" lIns="0" tIns="0" rIns="0" bIns="0" rtlCol="0" anchor="ctr"/>
-          <a:lstStyle/>
-          <a:p>
-            <a:pPr marL="0" indent="0">
-              <a:buNone/>
-            </a:pPr>
-            <a:r>
-              <a:rPr lang="en-US" sz="900" kern="0" spc="300" dirty="0">
-                <a:solidFill>
-                  <a:srgbClr val="9AA3AF"/>
-                </a:solidFill>
-                <a:latin typeface="Inter" pitchFamily="34" charset="0"/>
-                <a:ea typeface="Inter" pitchFamily="34" charset="-122"/>
-                <a:cs typeface="Inter" pitchFamily="34" charset="-120"/>
-              </a:rPr>
-              <a:t>01 · WELCOME &amp; KICKOFF</a:t>
-            </a:r>
-            <a:endParaRPr lang="en-US" sz="900" dirty="0"/>
-          </a:p>
-        </p:txBody>
-      </p:sp>
-      <p:sp>
-        <p:nvSpPr>
-          <p:cNvPr id="36" name="Text 34"/>
-          <p:cNvSpPr/>
-          <p:nvPr/>
-        </p:nvSpPr>
-        <p:spPr>
-          <a:xfrm>
-            <a:off x="8076895" y="6446520"/>
-            <a:ext cx="3657600" cy="274320"/>
-          </a:xfrm>
-          <a:prstGeom prst="rect">
-            <a:avLst/>
-          </a:prstGeom>
-          <a:noFill/>
-          <a:ln/>
-        </p:spPr>
-        <p:txBody>
-          <a:bodyPr wrap="square" lIns="0" tIns="0" rIns="0" bIns="0" rtlCol="0" anchor="ctr"/>
-          <a:lstStyle/>
-          <a:p>
-            <a:pPr marL="0" indent="0" algn="r">
-              <a:buNone/>
-            </a:pPr>
-            <a:r>
-              <a:rPr lang="en-US" sz="900" kern="0" spc="300" dirty="0">
-                <a:solidFill>
-                  <a:srgbClr val="9AA3AF"/>
-                </a:solidFill>
-                <a:latin typeface="Inter" pitchFamily="34" charset="0"/>
-                <a:ea typeface="Inter" pitchFamily="34" charset="-122"/>
-                <a:cs typeface="Inter" pitchFamily="34" charset="-120"/>
-              </a:rPr>
-              <a:t>ECHOES ALL WEEKEND</a:t>
-            </a:r>
-            <a:endParaRPr lang="en-US" sz="900" dirty="0"/>
-          </a:p>
-        </p:txBody>
-      </p:sp>
-    </p:spTree>
-  </p:cSld>
-  <p:clrMapOvr>
-    <a:masterClrMapping/>
-  </p:clrMapOvr>
-</p:sld>
-</file>
-
-<file path=ppt/slides/slide12.xml><?xml version="1.0" encoding="utf-8"?>
 <p:sld xmlns:a="http://schemas.openxmlformats.org/drawingml/2006/main" xmlns:r="http://schemas.openxmlformats.org/officeDocument/2006/relationships" xmlns:p="http://schemas.openxmlformats.org/presentationml/2006/main">
   <p:cSld name="Slide 10">
     <p:bg>
@@ -8198,7 +6787,7 @@
                 <a:ea typeface="Inter" pitchFamily="34" charset="-122"/>
                 <a:cs typeface="Inter" pitchFamily="34" charset="-120"/>
               </a:rPr>
-              <a:t>PRTDUD workflow overview</a:t>
+              <a:t>Context Engineering Workflow Overview</a:t>
             </a:r>
             <a:endParaRPr lang="en-US" sz="1200" dirty="0"/>
           </a:p>
@@ -8496,7 +7085,7 @@
                 <a:ea typeface="Inter" pitchFamily="34" charset="-122"/>
                 <a:cs typeface="Inter" pitchFamily="34" charset="-120"/>
               </a:rPr>
-              <a:t>Build Block 2 — execute &amp; test</a:t>
+              <a:t>Build Block 2 — code &amp; commit</a:t>
             </a:r>
             <a:endParaRPr lang="en-US" sz="1200" dirty="0"/>
           </a:p>
@@ -8517,7 +7106,7 @@
                 <a:ea typeface="Inter" pitchFamily="34" charset="-122"/>
                 <a:cs typeface="Inter" pitchFamily="34" charset="-120"/>
               </a:rPr>
-              <a:t>Deploying to Vercel</a:t>
+              <a:t>Deploying – ship it</a:t>
             </a:r>
             <a:endParaRPr lang="en-US" sz="1200" dirty="0"/>
           </a:p>
@@ -9908,61 +8497,36 @@
           </a:p>
         </p:txBody>
       </p:sp>
-      <p:sp>
-        <p:nvSpPr>
-          <p:cNvPr id="29" name="Google Shape;29;p2"/>
-          <p:cNvSpPr/>
-          <p:nvPr/>
-        </p:nvSpPr>
-        <p:spPr>
-          <a:xfrm>
-            <a:off x="1806873" y="3136900"/>
-            <a:ext cx="2295000" cy="1879600"/>
-          </a:xfrm>
-          <a:prstGeom prst="rect">
-            <a:avLst/>
-          </a:prstGeom>
-          <a:noFill/>
+      <p:pic>
+        <p:nvPicPr>
+          <p:cNvPr id="29" name="Avatar"/>
+          <p:cNvPicPr>
+            <a:picLocks noChangeAspect="1"/>
+          </p:cNvPicPr>
+          <p:nvPr/>
+        </p:nvPicPr>
+        <p:blipFill>
+          <a:blip r:embed="rId3"/>
+          <a:srcRect/>
+          <a:stretch>
+            <a:fillRect/>
+          </a:stretch>
+        </p:blipFill>
+        <p:spPr>
+          <a:xfrm>
+            <a:off x="863600" y="2006600"/>
+            <a:ext cx="4114800" cy="4114800"/>
+          </a:xfrm>
+          <a:prstGeom prst="roundRect">
+            <a:avLst>
+              <a:gd name="adj" fmla="val 2778"/>
+            </a:avLst>
+          </a:prstGeom>
           <a:ln>
             <a:noFill/>
           </a:ln>
         </p:spPr>
-        <p:txBody>
-          <a:bodyPr spcFirstLastPara="1" wrap="square" lIns="16933" tIns="16933" rIns="16933" bIns="16933" anchor="t" anchorCtr="0">
-            <a:normAutofit/>
-          </a:bodyPr>
-          <a:lstStyle/>
-          <a:p>
-            <a:pPr>
-              <a:buClr>
-                <a:srgbClr val="3FE0D0"/>
-              </a:buClr>
-              <a:buSzPts val="18000"/>
-            </a:pPr>
-            <a:r>
-              <a:rPr lang="en-US" sz="12001" b="1" dirty="0">
-                <a:solidFill>
-                  <a:srgbClr val="3FE0D0"/>
-                </a:solidFill>
-                <a:latin typeface="Montserrat"/>
-                <a:ea typeface="Montserrat"/>
-                <a:cs typeface="Montserrat"/>
-                <a:sym typeface="Montserrat"/>
-              </a:rPr>
-              <a:t>CK</a:t>
-            </a:r>
-            <a:endParaRPr sz="12001" dirty="0">
-              <a:solidFill>
-                <a:schemeClr val="dk1"/>
-              </a:solidFill>
-              <a:latin typeface="Calibri"/>
-              <a:ea typeface="Calibri"/>
-              <a:cs typeface="Calibri"/>
-              <a:sym typeface="Calibri"/>
-            </a:endParaRPr>
-          </a:p>
-        </p:txBody>
-      </p:sp>
+      </p:pic>
       <p:sp>
         <p:nvSpPr>
           <p:cNvPr id="30" name="Google Shape;30;p2"/>

</xml_diff>

<commit_message>
Updated the slide decks
</commit_message>
<xml_diff>
--- a/schedule/01-welcome-kickoff/01-welcome-kickoff.pptx
+++ b/schedule/01-welcome-kickoff/01-welcome-kickoff.pptx
@@ -204,7 +204,7 @@
           <a:p>
             <a:fld id="{9440A35C-DBD2-4A64-A6BF-7C1DF79DB2B6}" type="datetimeFigureOut">
               <a:rPr lang="en-US" smtClean="0"/>
-              <a:t>5/5/2026</a:t>
+              <a:t>5/6/26</a:t>
             </a:fld>
             <a:endParaRPr lang="en-US"/>
           </a:p>
@@ -5038,7 +5038,7 @@
                 <a:ea typeface="Inter" pitchFamily="34" charset="-122"/>
                 <a:cs typeface="Inter" pitchFamily="34" charset="-120"/>
               </a:rPr>
-              <a:t>claude, gh, node — all green before 10:00 AM. If not, we have people who can help.</a:t>
+              <a:t>claude, gh, node — all green. If not, we have people who can help.</a:t>
             </a:r>
             <a:endParaRPr lang="en-US" sz="1300" dirty="0"/>
           </a:p>
@@ -5374,7 +5374,7 @@
                 <a:ea typeface="Inter" pitchFamily="34" charset="-122"/>
                 <a:cs typeface="Inter" pitchFamily="34" charset="-120"/>
               </a:rPr>
-              <a:t>2 min</a:t>
+              <a:t>10 min</a:t>
             </a:r>
             <a:endParaRPr lang="en-US" sz="1400" dirty="0"/>
           </a:p>
@@ -5815,7 +5815,7 @@
                 <a:ea typeface="Inter" pitchFamily="34" charset="-122"/>
                 <a:cs typeface="Inter" pitchFamily="34" charset="-120"/>
               </a:rPr>
-              <a:t>3 min</a:t>
+              <a:t>5 min</a:t>
             </a:r>
             <a:endParaRPr lang="en-US" sz="1400" dirty="0"/>
           </a:p>
@@ -6000,123 +6000,6 @@
       </p:sp>
       <p:sp>
         <p:nvSpPr>
-          <p:cNvPr id="25" name="Text 23"/>
-          <p:cNvSpPr/>
-          <p:nvPr/>
-        </p:nvSpPr>
-        <p:spPr>
-          <a:xfrm>
-            <a:off x="548640" y="4754880"/>
-            <a:ext cx="731520" cy="548640"/>
-          </a:xfrm>
-          <a:prstGeom prst="rect">
-            <a:avLst/>
-          </a:prstGeom>
-          <a:noFill/>
-          <a:ln/>
-        </p:spPr>
-        <p:txBody>
-          <a:bodyPr wrap="square" lIns="0" tIns="0" rIns="0" bIns="0" rtlCol="0" anchor="ctr"/>
-          <a:lstStyle/>
-          <a:p>
-            <a:pPr marL="0" indent="0">
-              <a:buNone/>
-            </a:pPr>
-            <a:r>
-              <a:rPr lang="en-US" sz="1600" b="1" dirty="0">
-                <a:solidFill>
-                  <a:srgbClr val="E89B3C"/>
-                </a:solidFill>
-                <a:latin typeface="Montserrat" pitchFamily="34" charset="0"/>
-                <a:ea typeface="Montserrat" pitchFamily="34" charset="-122"/>
-                <a:cs typeface="Montserrat" pitchFamily="34" charset="-120"/>
-              </a:rPr>
-              <a:t>06</a:t>
-            </a:r>
-            <a:endParaRPr lang="en-US" sz="1600" dirty="0"/>
-          </a:p>
-        </p:txBody>
-      </p:sp>
-      <p:sp>
-        <p:nvSpPr>
-          <p:cNvPr id="26" name="Text 24"/>
-          <p:cNvSpPr/>
-          <p:nvPr/>
-        </p:nvSpPr>
-        <p:spPr>
-          <a:xfrm>
-            <a:off x="1371600" y="4754880"/>
-            <a:ext cx="8686800" cy="548640"/>
-          </a:xfrm>
-          <a:prstGeom prst="rect">
-            <a:avLst/>
-          </a:prstGeom>
-          <a:noFill/>
-          <a:ln/>
-        </p:spPr>
-        <p:txBody>
-          <a:bodyPr wrap="square" lIns="0" tIns="0" rIns="0" bIns="0" rtlCol="0" anchor="ctr"/>
-          <a:lstStyle/>
-          <a:p>
-            <a:pPr marL="0" indent="0">
-              <a:buNone/>
-            </a:pPr>
-            <a:r>
-              <a:rPr lang="en-US" sz="1600" dirty="0">
-                <a:solidFill>
-                  <a:srgbClr val="1F2937"/>
-                </a:solidFill>
-                <a:latin typeface="Inter" pitchFamily="34" charset="0"/>
-                <a:ea typeface="Inter" pitchFamily="34" charset="-122"/>
-                <a:cs typeface="Inter" pitchFamily="34" charset="-120"/>
-              </a:rPr>
-              <a:t>Setup check — live walk through prerequisites</a:t>
-            </a:r>
-            <a:endParaRPr lang="en-US" sz="1600" dirty="0"/>
-          </a:p>
-        </p:txBody>
-      </p:sp>
-      <p:sp>
-        <p:nvSpPr>
-          <p:cNvPr id="27" name="Text 25"/>
-          <p:cNvSpPr/>
-          <p:nvPr/>
-        </p:nvSpPr>
-        <p:spPr>
-          <a:xfrm>
-            <a:off x="10088575" y="4754880"/>
-            <a:ext cx="1554480" cy="548640"/>
-          </a:xfrm>
-          <a:prstGeom prst="rect">
-            <a:avLst/>
-          </a:prstGeom>
-          <a:noFill/>
-          <a:ln/>
-        </p:spPr>
-        <p:txBody>
-          <a:bodyPr wrap="square" lIns="0" tIns="0" rIns="0" bIns="0" rtlCol="0" anchor="ctr"/>
-          <a:lstStyle/>
-          <a:p>
-            <a:pPr marL="0" indent="0" algn="r">
-              <a:buNone/>
-            </a:pPr>
-            <a:r>
-              <a:rPr lang="en-US" sz="1400" kern="0" spc="200" dirty="0">
-                <a:solidFill>
-                  <a:srgbClr val="6B7280"/>
-                </a:solidFill>
-                <a:latin typeface="Inter" pitchFamily="34" charset="0"/>
-                <a:ea typeface="Inter" pitchFamily="34" charset="-122"/>
-                <a:cs typeface="Inter" pitchFamily="34" charset="-120"/>
-              </a:rPr>
-              <a:t>8 min</a:t>
-            </a:r>
-            <a:endParaRPr lang="en-US" sz="1400" dirty="0"/>
-          </a:p>
-        </p:txBody>
-      </p:sp>
-      <p:sp>
-        <p:nvSpPr>
           <p:cNvPr id="28" name="Shape 26"/>
           <p:cNvSpPr/>
           <p:nvPr/>
@@ -6142,123 +6025,6 @@
           <a:lstStyle/>
           <a:p>
             <a:endParaRPr lang="en-US"/>
-          </a:p>
-        </p:txBody>
-      </p:sp>
-      <p:sp>
-        <p:nvSpPr>
-          <p:cNvPr id="29" name="Text 27"/>
-          <p:cNvSpPr/>
-          <p:nvPr/>
-        </p:nvSpPr>
-        <p:spPr>
-          <a:xfrm>
-            <a:off x="548640" y="5303520"/>
-            <a:ext cx="731520" cy="548640"/>
-          </a:xfrm>
-          <a:prstGeom prst="rect">
-            <a:avLst/>
-          </a:prstGeom>
-          <a:noFill/>
-          <a:ln/>
-        </p:spPr>
-        <p:txBody>
-          <a:bodyPr wrap="square" lIns="0" tIns="0" rIns="0" bIns="0" rtlCol="0" anchor="ctr"/>
-          <a:lstStyle/>
-          <a:p>
-            <a:pPr marL="0" indent="0">
-              <a:buNone/>
-            </a:pPr>
-            <a:r>
-              <a:rPr lang="en-US" sz="1600" b="1" dirty="0">
-                <a:solidFill>
-                  <a:srgbClr val="E89B3C"/>
-                </a:solidFill>
-                <a:latin typeface="Montserrat" pitchFamily="34" charset="0"/>
-                <a:ea typeface="Montserrat" pitchFamily="34" charset="-122"/>
-                <a:cs typeface="Montserrat" pitchFamily="34" charset="-120"/>
-              </a:rPr>
-              <a:t>07</a:t>
-            </a:r>
-            <a:endParaRPr lang="en-US" sz="1600" dirty="0"/>
-          </a:p>
-        </p:txBody>
-      </p:sp>
-      <p:sp>
-        <p:nvSpPr>
-          <p:cNvPr id="30" name="Text 28"/>
-          <p:cNvSpPr/>
-          <p:nvPr/>
-        </p:nvSpPr>
-        <p:spPr>
-          <a:xfrm>
-            <a:off x="1371600" y="5303520"/>
-            <a:ext cx="8686800" cy="548640"/>
-          </a:xfrm>
-          <a:prstGeom prst="rect">
-            <a:avLst/>
-          </a:prstGeom>
-          <a:noFill/>
-          <a:ln/>
-        </p:spPr>
-        <p:txBody>
-          <a:bodyPr wrap="square" lIns="0" tIns="0" rIns="0" bIns="0" rtlCol="0" anchor="ctr"/>
-          <a:lstStyle/>
-          <a:p>
-            <a:pPr marL="0" indent="0">
-              <a:buNone/>
-            </a:pPr>
-            <a:r>
-              <a:rPr lang="en-US" sz="1600" dirty="0">
-                <a:solidFill>
-                  <a:srgbClr val="1F2937"/>
-                </a:solidFill>
-                <a:latin typeface="Inter" pitchFamily="34" charset="0"/>
-                <a:ea typeface="Inter" pitchFamily="34" charset="-122"/>
-                <a:cs typeface="Inter" pitchFamily="34" charset="-120"/>
-              </a:rPr>
-              <a:t>Hand-off</a:t>
-            </a:r>
-            <a:endParaRPr lang="en-US" sz="1600" dirty="0"/>
-          </a:p>
-        </p:txBody>
-      </p:sp>
-      <p:sp>
-        <p:nvSpPr>
-          <p:cNvPr id="31" name="Text 29"/>
-          <p:cNvSpPr/>
-          <p:nvPr/>
-        </p:nvSpPr>
-        <p:spPr>
-          <a:xfrm>
-            <a:off x="10088575" y="5303520"/>
-            <a:ext cx="1554480" cy="548640"/>
-          </a:xfrm>
-          <a:prstGeom prst="rect">
-            <a:avLst/>
-          </a:prstGeom>
-          <a:noFill/>
-          <a:ln/>
-        </p:spPr>
-        <p:txBody>
-          <a:bodyPr wrap="square" lIns="0" tIns="0" rIns="0" bIns="0" rtlCol="0" anchor="ctr"/>
-          <a:lstStyle/>
-          <a:p>
-            <a:pPr marL="0" indent="0" algn="r">
-              <a:buNone/>
-            </a:pPr>
-            <a:r>
-              <a:rPr lang="en-US" sz="1400" kern="0" spc="200" dirty="0">
-                <a:solidFill>
-                  <a:srgbClr val="6B7280"/>
-                </a:solidFill>
-                <a:latin typeface="Inter" pitchFamily="34" charset="0"/>
-                <a:ea typeface="Inter" pitchFamily="34" charset="-122"/>
-                <a:cs typeface="Inter" pitchFamily="34" charset="-120"/>
-              </a:rPr>
-              <a:t>2 min</a:t>
-            </a:r>
-            <a:endParaRPr lang="en-US" sz="1400" dirty="0"/>
           </a:p>
         </p:txBody>
       </p:sp>
@@ -7022,7 +6788,7 @@
                 <a:ea typeface="Inter" pitchFamily="34" charset="-122"/>
                 <a:cs typeface="Inter" pitchFamily="34" charset="-120"/>
               </a:rPr>
-              <a:t>Choosing your medium</a:t>
+              <a:t>Choosing your Claude Code Adventure</a:t>
             </a:r>
             <a:endParaRPr lang="en-US" sz="1200" dirty="0"/>
           </a:p>
@@ -8308,7 +8074,7 @@
                 <a:ea typeface="Montserrat" pitchFamily="34" charset="-122"/>
                 <a:cs typeface="Montserrat" pitchFamily="34" charset="-120"/>
               </a:rPr>
-              <a:t>Game's at 7. We'll be done.</a:t>
+              <a:t>Game is at 7. We'll be done.</a:t>
             </a:r>
             <a:endParaRPr lang="en-US" sz="1900" dirty="0"/>
           </a:p>

</xml_diff>